<commit_message>
refresh: 2026-05-13 — 10 files
</commit_message>
<xml_diff>
--- a/reports/ELNY_executive_deck.pptx
+++ b/reports/ELNY_executive_deck.pptx
@@ -2410,16 +2410,9 @@
   <p:cSld name="Slide 1">
     <p:bg>
       <p:bgPr>
-        <a:blipFill dpi="0" rotWithShape="1">
-          <a:blip r:embed="rId1">
-            <a:lum/>
-          </a:blip>
-          <a:srcRect/>
-          <a:stretch>
-            <a:fillRect/>
-          </a:stretch>
-        </a:blipFill>
-        <a:effectLst/>
+        <a:solidFill>
+          <a:srgbClr val="1A1A1A"/>
+        </a:solidFill>
       </p:bgPr>
     </p:bg>
     <p:spTree>
@@ -2436,6 +2429,290 @@
           <a:chExt cx="0" cy="0"/>
         </a:xfrm>
       </p:grpSpPr>
+      <p:sp>
+        <p:nvSpPr>
+          <p:cNvPr id="2" name="Shape 0"/>
+          <p:cNvSpPr/>
+          <p:nvPr/>
+        </p:nvSpPr>
+        <p:spPr>
+          <a:xfrm>
+            <a:off x="4251960" y="1051560"/>
+            <a:ext cx="640080" cy="10973"/>
+          </a:xfrm>
+          <a:prstGeom prst="rect">
+            <a:avLst/>
+          </a:prstGeom>
+          <a:solidFill>
+            <a:srgbClr val="888888"/>
+          </a:solidFill>
+          <a:ln w="12700">
+            <a:solidFill>
+              <a:srgbClr val="FFFFFF"/>
+            </a:solidFill>
+            <a:prstDash val="solid"/>
+          </a:ln>
+        </p:spPr>
+      </p:sp>
+      <p:sp>
+        <p:nvSpPr>
+          <p:cNvPr id="3" name="Text 1"/>
+          <p:cNvSpPr/>
+          <p:nvPr/>
+        </p:nvSpPr>
+        <p:spPr>
+          <a:xfrm>
+            <a:off x="0" y="1325880"/>
+            <a:ext cx="9144000" cy="1005840"/>
+          </a:xfrm>
+          <a:prstGeom prst="rect">
+            <a:avLst/>
+          </a:prstGeom>
+          <a:noFill/>
+          <a:ln/>
+        </p:spPr>
+        <p:txBody>
+          <a:bodyPr wrap="square" lIns="0" tIns="0" rIns="0" bIns="0" rtlCol="0" anchor="ctr"/>
+          <a:lstStyle/>
+          <a:p>
+            <a:pPr algn="ctr" indent="0" marL="0">
+              <a:buNone/>
+            </a:pPr>
+            <a:r>
+              <a:rPr lang="en-US" sz="7200" dirty="0">
+                <a:solidFill>
+                  <a:srgbClr val="FFFFFF"/>
+                </a:solidFill>
+                <a:latin typeface="Montserrat" pitchFamily="34" charset="0"/>
+                <a:ea typeface="Montserrat" pitchFamily="34" charset="-122"/>
+                <a:cs typeface="Montserrat" pitchFamily="34" charset="-120"/>
+              </a:rPr>
+              <a:t>E  L  N  Y</a:t>
+            </a:r>
+            <a:endParaRPr lang="en-US" sz="7200" dirty="0"/>
+          </a:p>
+        </p:txBody>
+      </p:sp>
+      <p:sp>
+        <p:nvSpPr>
+          <p:cNvPr id="4" name="Text 2"/>
+          <p:cNvSpPr/>
+          <p:nvPr/>
+        </p:nvSpPr>
+        <p:spPr>
+          <a:xfrm>
+            <a:off x="0" y="2331720"/>
+            <a:ext cx="9144000" cy="274320"/>
+          </a:xfrm>
+          <a:prstGeom prst="rect">
+            <a:avLst/>
+          </a:prstGeom>
+          <a:noFill/>
+          <a:ln/>
+        </p:spPr>
+        <p:txBody>
+          <a:bodyPr wrap="square" lIns="0" tIns="0" rIns="0" bIns="0" rtlCol="0" anchor="ctr"/>
+          <a:lstStyle/>
+          <a:p>
+            <a:pPr algn="ctr" indent="0" marL="0">
+              <a:buNone/>
+            </a:pPr>
+            <a:r>
+              <a:rPr lang="en-US" sz="1100" dirty="0">
+                <a:solidFill>
+                  <a:srgbClr val="B8B0A0"/>
+                </a:solidFill>
+                <a:latin typeface="Calibri" pitchFamily="34" charset="0"/>
+                <a:ea typeface="Calibri" pitchFamily="34" charset="-122"/>
+                <a:cs typeface="Calibri" pitchFamily="34" charset="-120"/>
+              </a:rPr>
+              <a:t>S T . P E T E R S B U R G</a:t>
+            </a:r>
+            <a:endParaRPr lang="en-US" sz="1100" dirty="0"/>
+          </a:p>
+        </p:txBody>
+      </p:sp>
+      <p:sp>
+        <p:nvSpPr>
+          <p:cNvPr id="5" name="Shape 3"/>
+          <p:cNvSpPr/>
+          <p:nvPr/>
+        </p:nvSpPr>
+        <p:spPr>
+          <a:xfrm>
+            <a:off x="4407408" y="2715768"/>
+            <a:ext cx="329184" cy="10973"/>
+          </a:xfrm>
+          <a:prstGeom prst="rect">
+            <a:avLst/>
+          </a:prstGeom>
+          <a:solidFill>
+            <a:srgbClr val="888888"/>
+          </a:solidFill>
+          <a:ln w="12700">
+            <a:solidFill>
+              <a:srgbClr val="FFFFFF"/>
+            </a:solidFill>
+            <a:prstDash val="solid"/>
+          </a:ln>
+        </p:spPr>
+      </p:sp>
+      <p:sp>
+        <p:nvSpPr>
+          <p:cNvPr id="6" name="Text 4"/>
+          <p:cNvSpPr/>
+          <p:nvPr/>
+        </p:nvSpPr>
+        <p:spPr>
+          <a:xfrm>
+            <a:off x="0" y="2788920"/>
+            <a:ext cx="9144000" cy="411480"/>
+          </a:xfrm>
+          <a:prstGeom prst="rect">
+            <a:avLst/>
+          </a:prstGeom>
+          <a:noFill/>
+          <a:ln/>
+        </p:spPr>
+        <p:txBody>
+          <a:bodyPr wrap="square" lIns="0" tIns="0" rIns="0" bIns="0" rtlCol="0" anchor="ctr"/>
+          <a:lstStyle/>
+          <a:p>
+            <a:pPr algn="ctr" indent="0" marL="0">
+              <a:buNone/>
+            </a:pPr>
+            <a:r>
+              <a:rPr lang="en-US" sz="2200" b="1" dirty="0">
+                <a:solidFill>
+                  <a:srgbClr val="FDFAE1"/>
+                </a:solidFill>
+                <a:latin typeface="Montserrat" pitchFamily="34" charset="0"/>
+                <a:ea typeface="Montserrat" pitchFamily="34" charset="-122"/>
+                <a:cs typeface="Montserrat" pitchFamily="34" charset="-120"/>
+              </a:rPr>
+              <a:t>А  Н  А  Л  И  Т  И  К  А</a:t>
+            </a:r>
+            <a:endParaRPr lang="en-US" sz="2200" dirty="0"/>
+          </a:p>
+        </p:txBody>
+      </p:sp>
+      <p:sp>
+        <p:nvSpPr>
+          <p:cNvPr id="7" name="Text 5"/>
+          <p:cNvSpPr/>
+          <p:nvPr/>
+        </p:nvSpPr>
+        <p:spPr>
+          <a:xfrm>
+            <a:off x="0" y="3337560"/>
+            <a:ext cx="9144000" cy="365760"/>
+          </a:xfrm>
+          <a:prstGeom prst="rect">
+            <a:avLst/>
+          </a:prstGeom>
+          <a:noFill/>
+          <a:ln/>
+        </p:spPr>
+        <p:txBody>
+          <a:bodyPr wrap="square" lIns="0" tIns="0" rIns="0" bIns="0" rtlCol="0" anchor="ctr"/>
+          <a:lstStyle/>
+          <a:p>
+            <a:pPr algn="ctr" indent="0" marL="0">
+              <a:buNone/>
+            </a:pPr>
+            <a:r>
+              <a:rPr lang="en-US" sz="1800" dirty="0">
+                <a:solidFill>
+                  <a:srgbClr val="FFFFFF"/>
+                </a:solidFill>
+                <a:latin typeface="Calibri" pitchFamily="34" charset="0"/>
+                <a:ea typeface="Calibri" pitchFamily="34" charset="-122"/>
+                <a:cs typeface="Calibri" pitchFamily="34" charset="-120"/>
+              </a:rPr>
+              <a:t>Конкурентная аналитика  ·  v2</a:t>
+            </a:r>
+            <a:endParaRPr lang="en-US" sz="1800" dirty="0"/>
+          </a:p>
+        </p:txBody>
+      </p:sp>
+      <p:sp>
+        <p:nvSpPr>
+          <p:cNvPr id="8" name="Text 6"/>
+          <p:cNvSpPr/>
+          <p:nvPr/>
+        </p:nvSpPr>
+        <p:spPr>
+          <a:xfrm>
+            <a:off x="0" y="3703320"/>
+            <a:ext cx="9144000" cy="274320"/>
+          </a:xfrm>
+          <a:prstGeom prst="rect">
+            <a:avLst/>
+          </a:prstGeom>
+          <a:noFill/>
+          <a:ln/>
+        </p:spPr>
+        <p:txBody>
+          <a:bodyPr wrap="square" lIns="0" tIns="0" rIns="0" bIns="0" rtlCol="0" anchor="ctr"/>
+          <a:lstStyle/>
+          <a:p>
+            <a:pPr algn="ctr" indent="0" marL="0">
+              <a:buNone/>
+            </a:pPr>
+            <a:r>
+              <a:rPr lang="en-US" sz="1300" i="1" dirty="0">
+                <a:solidFill>
+                  <a:srgbClr val="B8B0A0"/>
+                </a:solidFill>
+                <a:latin typeface="Calibri" pitchFamily="34" charset="0"/>
+                <a:ea typeface="Calibri" pitchFamily="34" charset="-122"/>
+                <a:cs typeface="Calibri" pitchFamily="34" charset="-120"/>
+              </a:rPr>
+              <a:t>Расширенная аналитическая записка</a:t>
+            </a:r>
+            <a:endParaRPr lang="en-US" sz="1300" dirty="0"/>
+          </a:p>
+        </p:txBody>
+      </p:sp>
+      <p:sp>
+        <p:nvSpPr>
+          <p:cNvPr id="9" name="Text 7"/>
+          <p:cNvSpPr/>
+          <p:nvPr/>
+        </p:nvSpPr>
+        <p:spPr>
+          <a:xfrm>
+            <a:off x="0" y="4663440"/>
+            <a:ext cx="9144000" cy="228600"/>
+          </a:xfrm>
+          <a:prstGeom prst="rect">
+            <a:avLst/>
+          </a:prstGeom>
+          <a:noFill/>
+          <a:ln/>
+        </p:spPr>
+        <p:txBody>
+          <a:bodyPr wrap="square" lIns="0" tIns="0" rIns="0" bIns="0" rtlCol="0" anchor="ctr"/>
+          <a:lstStyle/>
+          <a:p>
+            <a:pPr algn="ctr" indent="0" marL="0">
+              <a:buNone/>
+            </a:pPr>
+            <a:r>
+              <a:rPr lang="en-US" sz="1000" dirty="0">
+                <a:solidFill>
+                  <a:srgbClr val="8A8275"/>
+                </a:solidFill>
+                <a:latin typeface="Calibri" pitchFamily="34" charset="0"/>
+                <a:ea typeface="Calibri" pitchFamily="34" charset="-122"/>
+                <a:cs typeface="Calibri" pitchFamily="34" charset="-120"/>
+              </a:rPr>
+              <a:t>Снапшот: 2026-05-11   ·   Версия: 2026-05-13</a:t>
+            </a:r>
+            <a:endParaRPr lang="en-US" sz="1000" dirty="0"/>
+          </a:p>
+        </p:txBody>
+      </p:sp>
     </p:spTree>
   </p:cSld>
   <p:clrMapOvr>

</xml_diff>